<commit_message>
Detail Onboard Router / Switch Fabric architecture
Add fabric deep-dive notes and four editable slides covering
topology, 58G-class SerDes, traffic classes, switching functions,
and an example lane plan for RX/TX/feeder ports.

Co-authored-by: rushikeshpurohit0908 <rushikeshpurohit0908@users.noreply.github.com>
</commit_message>
<xml_diff>
--- a/dra/DRA_Architecture_Editable_Slide.pptx
+++ b/dra/DRA_Architecture_Editable_Slide.pptx
@@ -5443,11 +5443,11 @@
           <a:p>
             <a:pPr algn="ctr">
               <a:spcAft>
-                <a:spcPts val="200"/>
+                <a:spcPts val="100"/>
               </a:spcAft>
             </a:pPr>
             <a:r>
-              <a:rPr sz="1400" b="0">
+              <a:rPr sz="1300" b="0">
                 <a:solidFill>
                   <a:srgbClr val="F2F6F9"/>
                 </a:solidFill>
@@ -5463,13 +5463,13 @@
               </a:spcAft>
             </a:pPr>
             <a:r>
-              <a:rPr sz="900" b="0">
+              <a:rPr sz="800" b="0">
                 <a:solidFill>
                   <a:srgbClr val="B8D0E8"/>
                 </a:solidFill>
                 <a:latin typeface="Calibri"/>
               </a:rPr>
-              <a:t>58 Gbps SerDes interconnect between device clusters and Feeder-link stage</a:t>
+              <a:t>58 Gbps-class SerDes  ·  Regenerative packet/TB switch (not raw IQ)  ·  RX ↔ TX ↔ Feeder</a:t>
             </a:r>
           </a:p>
         </p:txBody>

</xml_diff>